<commit_message>
Darken muted text and fix low-contrast fills; add a PDF export
Reported from a projector: the muted grey was not readable. It was 6B7A90 —
acceptable on a monitor, washed out when projected. Changed once at the palette
to 232C3A, which carries every subtitle, caption, node label and body line in
the deck to near-black.

Three places also had white text on the light cyan fill, roughly 2:1 contrast:
the scalability tiles, the numbered circles on the technical slide, and the
milestone markers on the roadmap. Those now take navy text on cyan (~7:1) while
the navy and periwinkle fills keep white. The architecture's calculation-engine
node was white on cyan too; it is now a navy fill with white text, which also
makes it read as the hero of that diagram.

Added a PDF alongside the .pptx for anyone who cannot open PowerPoint.

Validator passes, geometry check clean across all 15 slides.
</commit_message>
<xml_diff>
--- a/docs/presentation/BIET-Denovo-IBAB.pptx
+++ b/docs/presentation/BIET-Denovo-IBAB.pptx
@@ -3832,7 +3832,7 @@
             <a:r>
               <a:rPr lang="en-US" sz="1300" dirty="0">
                 <a:solidFill>
-                  <a:srgbClr val="6B7A90"/>
+                  <a:srgbClr val="232C3A"/>
                 </a:solidFill>
                 <a:latin typeface="Calibri" pitchFamily="34" charset="0"/>
                 <a:ea typeface="Calibri" pitchFamily="34" charset="-122"/>
@@ -4173,7 +4173,7 @@
             <a:r>
               <a:rPr lang="en-US" sz="1400" dirty="0">
                 <a:solidFill>
-                  <a:srgbClr val="6B7A90"/>
+                  <a:srgbClr val="232C3A"/>
                 </a:solidFill>
                 <a:latin typeface="Calibri" pitchFamily="34" charset="0"/>
                 <a:ea typeface="Calibri" pitchFamily="34" charset="-122"/>
@@ -4796,7 +4796,7 @@
             <a:r>
               <a:rPr lang="en-US" sz="1020" i="1" dirty="0">
                 <a:solidFill>
-                  <a:srgbClr val="6B7A90"/>
+                  <a:srgbClr val="232C3A"/>
                 </a:solidFill>
                 <a:latin typeface="Calibri" pitchFamily="34" charset="0"/>
                 <a:ea typeface="Calibri" pitchFamily="34" charset="-122"/>
@@ -5229,7 +5229,7 @@
             <a:r>
               <a:rPr lang="en-US" sz="950" dirty="0">
                 <a:solidFill>
-                  <a:srgbClr val="6B7A90"/>
+                  <a:srgbClr val="232C3A"/>
                 </a:solidFill>
                 <a:latin typeface="Calibri" pitchFamily="34" charset="0"/>
                 <a:ea typeface="Calibri" pitchFamily="34" charset="-122"/>
@@ -5443,7 +5443,7 @@
             <a:r>
               <a:rPr lang="en-US" sz="1400" dirty="0">
                 <a:solidFill>
-                  <a:srgbClr val="6B7A90"/>
+                  <a:srgbClr val="232C3A"/>
                 </a:solidFill>
                 <a:latin typeface="Calibri" pitchFamily="34" charset="0"/>
                 <a:ea typeface="Calibri" pitchFamily="34" charset="-122"/>
@@ -5609,7 +5609,7 @@
             <a:r>
               <a:rPr lang="en-US" sz="1080" dirty="0">
                 <a:solidFill>
-                  <a:srgbClr val="6B7A90"/>
+                  <a:srgbClr val="232C3A"/>
                 </a:solidFill>
                 <a:latin typeface="Calibri" pitchFamily="34" charset="0"/>
                 <a:ea typeface="Calibri" pitchFamily="34" charset="-122"/>
@@ -5712,7 +5712,7 @@
             <a:r>
               <a:rPr lang="en-US" sz="1080" dirty="0">
                 <a:solidFill>
-                  <a:srgbClr val="6B7A90"/>
+                  <a:srgbClr val="232C3A"/>
                 </a:solidFill>
                 <a:latin typeface="Calibri" pitchFamily="34" charset="0"/>
                 <a:ea typeface="Calibri" pitchFamily="34" charset="-122"/>
@@ -5815,7 +5815,7 @@
             <a:r>
               <a:rPr lang="en-US" sz="1080" dirty="0">
                 <a:solidFill>
-                  <a:srgbClr val="6B7A90"/>
+                  <a:srgbClr val="232C3A"/>
                 </a:solidFill>
                 <a:latin typeface="Calibri" pitchFamily="34" charset="0"/>
                 <a:ea typeface="Calibri" pitchFamily="34" charset="-122"/>
@@ -5918,7 +5918,7 @@
             <a:r>
               <a:rPr lang="en-US" sz="1080" dirty="0">
                 <a:solidFill>
-                  <a:srgbClr val="6B7A90"/>
+                  <a:srgbClr val="232C3A"/>
                 </a:solidFill>
                 <a:latin typeface="Calibri" pitchFamily="34" charset="0"/>
                 <a:ea typeface="Calibri" pitchFamily="34" charset="-122"/>
@@ -6021,7 +6021,7 @@
             <a:r>
               <a:rPr lang="en-US" sz="1080" dirty="0">
                 <a:solidFill>
-                  <a:srgbClr val="6B7A90"/>
+                  <a:srgbClr val="232C3A"/>
                 </a:solidFill>
                 <a:latin typeface="Calibri" pitchFamily="34" charset="0"/>
                 <a:ea typeface="Calibri" pitchFamily="34" charset="-122"/>
@@ -6129,7 +6129,7 @@
             <a:r>
               <a:rPr lang="en-US" sz="950" dirty="0">
                 <a:solidFill>
-                  <a:srgbClr val="6B7A90"/>
+                  <a:srgbClr val="232C3A"/>
                 </a:solidFill>
                 <a:latin typeface="Calibri" pitchFamily="34" charset="0"/>
                 <a:ea typeface="Calibri" pitchFamily="34" charset="-122"/>
@@ -6550,7 +6550,7 @@
             <a:r>
               <a:rPr lang="en-US" sz="1400" dirty="0">
                 <a:solidFill>
-                  <a:srgbClr val="6B7A90"/>
+                  <a:srgbClr val="232C3A"/>
                 </a:solidFill>
                 <a:latin typeface="Calibri" pitchFamily="34" charset="0"/>
                 <a:ea typeface="Calibri" pitchFamily="34" charset="-122"/>
@@ -7225,7 +7225,7 @@
             <a:r>
               <a:rPr lang="en-US" sz="950" dirty="0">
                 <a:solidFill>
-                  <a:srgbClr val="6B7A90"/>
+                  <a:srgbClr val="232C3A"/>
                 </a:solidFill>
                 <a:latin typeface="Calibri" pitchFamily="34" charset="0"/>
                 <a:ea typeface="Calibri" pitchFamily="34" charset="-122"/>
@@ -7876,7 +7876,7 @@
             <a:r>
               <a:rPr lang="en-US" sz="1400" dirty="0">
                 <a:solidFill>
-                  <a:srgbClr val="6B7A90"/>
+                  <a:srgbClr val="232C3A"/>
                 </a:solidFill>
                 <a:latin typeface="Calibri" pitchFamily="34" charset="0"/>
                 <a:ea typeface="Calibri" pitchFamily="34" charset="-122"/>
@@ -8023,7 +8023,7 @@
             <a:r>
               <a:rPr lang="en-US" sz="1200" dirty="0">
                 <a:solidFill>
-                  <a:srgbClr val="6B7A90"/>
+                  <a:srgbClr val="232C3A"/>
                 </a:solidFill>
                 <a:latin typeface="Calibri" pitchFamily="34" charset="0"/>
                 <a:ea typeface="Calibri" pitchFamily="34" charset="-122"/>
@@ -8170,7 +8170,7 @@
             <a:r>
               <a:rPr lang="en-US" sz="1200" dirty="0">
                 <a:solidFill>
-                  <a:srgbClr val="6B7A90"/>
+                  <a:srgbClr val="232C3A"/>
                 </a:solidFill>
                 <a:latin typeface="Calibri" pitchFamily="34" charset="0"/>
                 <a:ea typeface="Calibri" pitchFamily="34" charset="-122"/>
@@ -8236,7 +8236,7 @@
             <a:r>
               <a:rPr lang="en-US" sz="1300" b="1" dirty="0">
                 <a:solidFill>
-                  <a:srgbClr val="FFFFFF"/>
+                  <a:srgbClr val="12235B"/>
                 </a:solidFill>
                 <a:latin typeface="Calibri" pitchFamily="34" charset="0"/>
                 <a:ea typeface="Calibri" pitchFamily="34" charset="-122"/>
@@ -8317,7 +8317,7 @@
             <a:r>
               <a:rPr lang="en-US" sz="1200" dirty="0">
                 <a:solidFill>
-                  <a:srgbClr val="6B7A90"/>
+                  <a:srgbClr val="232C3A"/>
                 </a:solidFill>
                 <a:latin typeface="Calibri" pitchFamily="34" charset="0"/>
                 <a:ea typeface="Calibri" pitchFamily="34" charset="-122"/>
@@ -8356,7 +8356,7 @@
             <a:r>
               <a:rPr lang="en-US" sz="950" dirty="0">
                 <a:solidFill>
-                  <a:srgbClr val="6B7A90"/>
+                  <a:srgbClr val="232C3A"/>
                 </a:solidFill>
                 <a:latin typeface="Calibri" pitchFamily="34" charset="0"/>
                 <a:ea typeface="Calibri" pitchFamily="34" charset="-122"/>
@@ -8592,7 +8592,7 @@
             <a:r>
               <a:rPr lang="en-US" sz="1150" b="1" dirty="0">
                 <a:solidFill>
-                  <a:srgbClr val="FFFFFF"/>
+                  <a:srgbClr val="12235B"/>
                 </a:solidFill>
                 <a:latin typeface="Calibri" pitchFamily="34" charset="0"/>
                 <a:ea typeface="Calibri" pitchFamily="34" charset="-122"/>
@@ -8738,7 +8738,7 @@
             <a:r>
               <a:rPr lang="en-US" sz="1120" dirty="0">
                 <a:solidFill>
-                  <a:srgbClr val="6B7A90"/>
+                  <a:srgbClr val="232C3A"/>
                 </a:solidFill>
                 <a:latin typeface="Calibri" pitchFamily="34" charset="0"/>
                 <a:ea typeface="Calibri" pitchFamily="34" charset="-122"/>
@@ -8948,7 +8948,7 @@
             <a:r>
               <a:rPr lang="en-US" sz="1120" dirty="0">
                 <a:solidFill>
-                  <a:srgbClr val="6B7A90"/>
+                  <a:srgbClr val="232C3A"/>
                 </a:solidFill>
                 <a:latin typeface="Calibri" pitchFamily="34" charset="0"/>
                 <a:ea typeface="Calibri" pitchFamily="34" charset="-122"/>
@@ -9158,7 +9158,7 @@
             <a:r>
               <a:rPr lang="en-US" sz="1120" dirty="0">
                 <a:solidFill>
-                  <a:srgbClr val="6B7A90"/>
+                  <a:srgbClr val="232C3A"/>
                 </a:solidFill>
                 <a:latin typeface="Calibri" pitchFamily="34" charset="0"/>
                 <a:ea typeface="Calibri" pitchFamily="34" charset="-122"/>
@@ -9345,7 +9345,7 @@
             <a:r>
               <a:rPr lang="en-US" sz="1120" dirty="0">
                 <a:solidFill>
-                  <a:srgbClr val="6B7A90"/>
+                  <a:srgbClr val="232C3A"/>
                 </a:solidFill>
                 <a:latin typeface="Calibri" pitchFamily="34" charset="0"/>
                 <a:ea typeface="Calibri" pitchFamily="34" charset="-122"/>
@@ -9465,7 +9465,7 @@
             <a:r>
               <a:rPr lang="en-US" sz="1080" dirty="0">
                 <a:solidFill>
-                  <a:srgbClr val="6B7A90"/>
+                  <a:srgbClr val="232C3A"/>
                 </a:solidFill>
                 <a:latin typeface="Calibri" pitchFamily="34" charset="0"/>
                 <a:ea typeface="Calibri" pitchFamily="34" charset="-122"/>
@@ -9546,7 +9546,7 @@
             <a:r>
               <a:rPr lang="en-US" sz="1080" dirty="0">
                 <a:solidFill>
-                  <a:srgbClr val="6B7A90"/>
+                  <a:srgbClr val="232C3A"/>
                 </a:solidFill>
                 <a:latin typeface="Calibri" pitchFamily="34" charset="0"/>
                 <a:ea typeface="Calibri" pitchFamily="34" charset="-122"/>
@@ -9627,7 +9627,7 @@
             <a:r>
               <a:rPr lang="en-US" sz="1080" dirty="0">
                 <a:solidFill>
-                  <a:srgbClr val="6B7A90"/>
+                  <a:srgbClr val="232C3A"/>
                 </a:solidFill>
                 <a:latin typeface="Calibri" pitchFamily="34" charset="0"/>
                 <a:ea typeface="Calibri" pitchFamily="34" charset="-122"/>
@@ -9708,7 +9708,7 @@
             <a:r>
               <a:rPr lang="en-US" sz="1080" dirty="0">
                 <a:solidFill>
-                  <a:srgbClr val="6B7A90"/>
+                  <a:srgbClr val="232C3A"/>
                 </a:solidFill>
                 <a:latin typeface="Calibri" pitchFamily="34" charset="0"/>
                 <a:ea typeface="Calibri" pitchFamily="34" charset="-122"/>
@@ -9747,7 +9747,7 @@
             <a:r>
               <a:rPr lang="en-US" sz="950" dirty="0">
                 <a:solidFill>
-                  <a:srgbClr val="6B7A90"/>
+                  <a:srgbClr val="232C3A"/>
                 </a:solidFill>
                 <a:latin typeface="Calibri" pitchFamily="34" charset="0"/>
                 <a:ea typeface="Calibri" pitchFamily="34" charset="-122"/>
@@ -11782,7 +11782,7 @@
             <a:r>
               <a:rPr lang="en-US" sz="1240" dirty="0">
                 <a:solidFill>
-                  <a:srgbClr val="6B7A90"/>
+                  <a:srgbClr val="232C3A"/>
                 </a:solidFill>
                 <a:latin typeface="Calibri" pitchFamily="34" charset="0"/>
                 <a:ea typeface="Calibri" pitchFamily="34" charset="-122"/>
@@ -11961,7 +11961,7 @@
             <a:r>
               <a:rPr lang="en-US" sz="1240" dirty="0">
                 <a:solidFill>
-                  <a:srgbClr val="6B7A90"/>
+                  <a:srgbClr val="232C3A"/>
                 </a:solidFill>
                 <a:latin typeface="Calibri" pitchFamily="34" charset="0"/>
                 <a:ea typeface="Calibri" pitchFamily="34" charset="-122"/>
@@ -12140,7 +12140,7 @@
             <a:r>
               <a:rPr lang="en-US" sz="1240" dirty="0">
                 <a:solidFill>
-                  <a:srgbClr val="6B7A90"/>
+                  <a:srgbClr val="232C3A"/>
                 </a:solidFill>
                 <a:latin typeface="Calibri" pitchFamily="34" charset="0"/>
                 <a:ea typeface="Calibri" pitchFamily="34" charset="-122"/>
@@ -12319,7 +12319,7 @@
             <a:r>
               <a:rPr lang="en-US" sz="1240" dirty="0">
                 <a:solidFill>
-                  <a:srgbClr val="6B7A90"/>
+                  <a:srgbClr val="232C3A"/>
                 </a:solidFill>
                 <a:latin typeface="Calibri" pitchFamily="34" charset="0"/>
                 <a:ea typeface="Calibri" pitchFamily="34" charset="-122"/>
@@ -12498,7 +12498,7 @@
             <a:r>
               <a:rPr lang="en-US" sz="1240" dirty="0">
                 <a:solidFill>
-                  <a:srgbClr val="6B7A90"/>
+                  <a:srgbClr val="232C3A"/>
                 </a:solidFill>
                 <a:latin typeface="Calibri" pitchFamily="34" charset="0"/>
                 <a:ea typeface="Calibri" pitchFamily="34" charset="-122"/>
@@ -12677,7 +12677,7 @@
             <a:r>
               <a:rPr lang="en-US" sz="1240" dirty="0">
                 <a:solidFill>
-                  <a:srgbClr val="6B7A90"/>
+                  <a:srgbClr val="232C3A"/>
                 </a:solidFill>
                 <a:latin typeface="Calibri" pitchFamily="34" charset="0"/>
                 <a:ea typeface="Calibri" pitchFamily="34" charset="-122"/>
@@ -12856,7 +12856,7 @@
             <a:r>
               <a:rPr lang="en-US" sz="1240" dirty="0">
                 <a:solidFill>
-                  <a:srgbClr val="6B7A90"/>
+                  <a:srgbClr val="232C3A"/>
                 </a:solidFill>
                 <a:latin typeface="Calibri" pitchFamily="34" charset="0"/>
                 <a:ea typeface="Calibri" pitchFamily="34" charset="-122"/>
@@ -12934,7 +12934,7 @@
             <a:r>
               <a:rPr lang="en-US" sz="950" dirty="0">
                 <a:solidFill>
-                  <a:srgbClr val="6B7A90"/>
+                  <a:srgbClr val="232C3A"/>
                 </a:solidFill>
                 <a:latin typeface="Calibri" pitchFamily="34" charset="0"/>
                 <a:ea typeface="Calibri" pitchFamily="34" charset="-122"/>
@@ -13449,7 +13449,7 @@
             <a:r>
               <a:rPr lang="en-US" sz="1400" dirty="0">
                 <a:solidFill>
-                  <a:srgbClr val="6B7A90"/>
+                  <a:srgbClr val="232C3A"/>
                 </a:solidFill>
                 <a:latin typeface="Calibri" pitchFamily="34" charset="0"/>
                 <a:ea typeface="Calibri" pitchFamily="34" charset="-122"/>
@@ -13754,7 +13754,7 @@
             <a:r>
               <a:rPr lang="en-US" sz="1160" dirty="0">
                 <a:solidFill>
-                  <a:srgbClr val="6B7A90"/>
+                  <a:srgbClr val="232C3A"/>
                 </a:solidFill>
                 <a:latin typeface="Calibri" pitchFamily="34" charset="0"/>
                 <a:ea typeface="Calibri" pitchFamily="34" charset="-122"/>
@@ -13860,7 +13860,7 @@
             <a:r>
               <a:rPr lang="en-US" sz="1160" dirty="0">
                 <a:solidFill>
-                  <a:srgbClr val="6B7A90"/>
+                  <a:srgbClr val="232C3A"/>
                 </a:solidFill>
                 <a:latin typeface="Calibri" pitchFamily="34" charset="0"/>
                 <a:ea typeface="Calibri" pitchFamily="34" charset="-122"/>
@@ -13966,7 +13966,7 @@
             <a:r>
               <a:rPr lang="en-US" sz="1160" dirty="0">
                 <a:solidFill>
-                  <a:srgbClr val="6B7A90"/>
+                  <a:srgbClr val="232C3A"/>
                 </a:solidFill>
                 <a:latin typeface="Calibri" pitchFamily="34" charset="0"/>
                 <a:ea typeface="Calibri" pitchFamily="34" charset="-122"/>
@@ -14074,7 +14074,7 @@
             <a:r>
               <a:rPr lang="en-US" sz="950" dirty="0">
                 <a:solidFill>
-                  <a:srgbClr val="6B7A90"/>
+                  <a:srgbClr val="232C3A"/>
                 </a:solidFill>
                 <a:latin typeface="Calibri" pitchFamily="34" charset="0"/>
                 <a:ea typeface="Calibri" pitchFamily="34" charset="-122"/>
@@ -14771,7 +14771,7 @@
             <a:r>
               <a:rPr lang="en-US" sz="1400" dirty="0">
                 <a:solidFill>
-                  <a:srgbClr val="6B7A90"/>
+                  <a:srgbClr val="232C3A"/>
                 </a:solidFill>
                 <a:latin typeface="Calibri" pitchFamily="34" charset="0"/>
                 <a:ea typeface="Calibri" pitchFamily="34" charset="-122"/>
@@ -14921,7 +14921,7 @@
             <a:r>
               <a:rPr lang="en-US" sz="1180" dirty="0">
                 <a:solidFill>
-                  <a:srgbClr val="6B7A90"/>
+                  <a:srgbClr val="232C3A"/>
                 </a:solidFill>
                 <a:latin typeface="Calibri" pitchFamily="34" charset="0"/>
                 <a:ea typeface="Calibri" pitchFamily="34" charset="-122"/>
@@ -15071,7 +15071,7 @@
             <a:r>
               <a:rPr lang="en-US" sz="1180" dirty="0">
                 <a:solidFill>
-                  <a:srgbClr val="6B7A90"/>
+                  <a:srgbClr val="232C3A"/>
                 </a:solidFill>
                 <a:latin typeface="Calibri" pitchFamily="34" charset="0"/>
                 <a:ea typeface="Calibri" pitchFamily="34" charset="-122"/>
@@ -15221,7 +15221,7 @@
             <a:r>
               <a:rPr lang="en-US" sz="1180" dirty="0">
                 <a:solidFill>
-                  <a:srgbClr val="6B7A90"/>
+                  <a:srgbClr val="232C3A"/>
                 </a:solidFill>
                 <a:latin typeface="Calibri" pitchFamily="34" charset="0"/>
                 <a:ea typeface="Calibri" pitchFamily="34" charset="-122"/>
@@ -15341,7 +15341,7 @@
             <a:r>
               <a:rPr lang="en-US" sz="950" dirty="0">
                 <a:solidFill>
-                  <a:srgbClr val="6B7A90"/>
+                  <a:srgbClr val="232C3A"/>
                 </a:solidFill>
                 <a:latin typeface="Calibri" pitchFamily="34" charset="0"/>
                 <a:ea typeface="Calibri" pitchFamily="34" charset="-122"/>
@@ -15580,7 +15580,7 @@
             <a:r>
               <a:rPr lang="en-US" sz="1400" dirty="0">
                 <a:solidFill>
-                  <a:srgbClr val="6B7A90"/>
+                  <a:srgbClr val="232C3A"/>
                 </a:solidFill>
                 <a:latin typeface="Calibri" pitchFamily="34" charset="0"/>
                 <a:ea typeface="Calibri" pitchFamily="34" charset="-122"/>
@@ -16556,7 +16556,7 @@
             <a:r>
               <a:rPr lang="en-US" sz="1020" i="1" dirty="0">
                 <a:solidFill>
-                  <a:srgbClr val="6B7A90"/>
+                  <a:srgbClr val="232C3A"/>
                 </a:solidFill>
                 <a:latin typeface="Calibri" pitchFamily="34" charset="0"/>
                 <a:ea typeface="Calibri" pitchFamily="34" charset="-122"/>
@@ -16994,7 +16994,7 @@
             <a:r>
               <a:rPr lang="en-US" sz="950" dirty="0">
                 <a:solidFill>
-                  <a:srgbClr val="6B7A90"/>
+                  <a:srgbClr val="232C3A"/>
                 </a:solidFill>
                 <a:latin typeface="Calibri" pitchFamily="34" charset="0"/>
                 <a:ea typeface="Calibri" pitchFamily="34" charset="-122"/>
@@ -17438,7 +17438,7 @@
             <a:r>
               <a:rPr lang="en-US" sz="1400" dirty="0">
                 <a:solidFill>
-                  <a:srgbClr val="6B7A90"/>
+                  <a:srgbClr val="232C3A"/>
                 </a:solidFill>
                 <a:latin typeface="Calibri" pitchFamily="34" charset="0"/>
                 <a:ea typeface="Calibri" pitchFamily="34" charset="-122"/>
@@ -17504,7 +17504,7 @@
             <a:r>
               <a:rPr lang="en-US" sz="1020" i="1" dirty="0">
                 <a:solidFill>
-                  <a:srgbClr val="6B7A90"/>
+                  <a:srgbClr val="232C3A"/>
                 </a:solidFill>
                 <a:latin typeface="Calibri" pitchFamily="34" charset="0"/>
                 <a:ea typeface="Calibri" pitchFamily="34" charset="-122"/>
@@ -17727,7 +17727,7 @@
             <a:r>
               <a:rPr lang="en-US" sz="1100" dirty="0">
                 <a:solidFill>
-                  <a:srgbClr val="6B7A90"/>
+                  <a:srgbClr val="232C3A"/>
                 </a:solidFill>
                 <a:latin typeface="Calibri" pitchFamily="34" charset="0"/>
                 <a:ea typeface="Calibri" pitchFamily="34" charset="-122"/>
@@ -17844,7 +17844,7 @@
             <a:r>
               <a:rPr lang="en-US" sz="1100" dirty="0">
                 <a:solidFill>
-                  <a:srgbClr val="6B7A90"/>
+                  <a:srgbClr val="232C3A"/>
                 </a:solidFill>
                 <a:latin typeface="Calibri" pitchFamily="34" charset="0"/>
                 <a:ea typeface="Calibri" pitchFamily="34" charset="-122"/>
@@ -17961,7 +17961,7 @@
             <a:r>
               <a:rPr lang="en-US" sz="1100" dirty="0">
                 <a:solidFill>
-                  <a:srgbClr val="6B7A90"/>
+                  <a:srgbClr val="232C3A"/>
                 </a:solidFill>
                 <a:latin typeface="Calibri" pitchFamily="34" charset="0"/>
                 <a:ea typeface="Calibri" pitchFamily="34" charset="-122"/>
@@ -18078,7 +18078,7 @@
             <a:r>
               <a:rPr lang="en-US" sz="1100" dirty="0">
                 <a:solidFill>
-                  <a:srgbClr val="6B7A90"/>
+                  <a:srgbClr val="232C3A"/>
                 </a:solidFill>
                 <a:latin typeface="Calibri" pitchFamily="34" charset="0"/>
                 <a:ea typeface="Calibri" pitchFamily="34" charset="-122"/>
@@ -18195,7 +18195,7 @@
             <a:r>
               <a:rPr lang="en-US" sz="1100" dirty="0">
                 <a:solidFill>
-                  <a:srgbClr val="6B7A90"/>
+                  <a:srgbClr val="232C3A"/>
                 </a:solidFill>
                 <a:latin typeface="Calibri" pitchFamily="34" charset="0"/>
                 <a:ea typeface="Calibri" pitchFamily="34" charset="-122"/>
@@ -18339,7 +18339,7 @@
             <a:r>
               <a:rPr lang="en-US" sz="1100" dirty="0">
                 <a:solidFill>
-                  <a:srgbClr val="6B7A90"/>
+                  <a:srgbClr val="232C3A"/>
                 </a:solidFill>
                 <a:latin typeface="Calibri" pitchFamily="34" charset="0"/>
                 <a:ea typeface="Calibri" pitchFamily="34" charset="-122"/>
@@ -18420,7 +18420,7 @@
             <a:r>
               <a:rPr lang="en-US" sz="1140" dirty="0">
                 <a:solidFill>
-                  <a:srgbClr val="6B7A90"/>
+                  <a:srgbClr val="232C3A"/>
                 </a:solidFill>
                 <a:latin typeface="Calibri" pitchFamily="34" charset="0"/>
                 <a:ea typeface="Calibri" pitchFamily="34" charset="-122"/>
@@ -18459,7 +18459,7 @@
             <a:r>
               <a:rPr lang="en-US" sz="950" dirty="0">
                 <a:solidFill>
-                  <a:srgbClr val="6B7A90"/>
+                  <a:srgbClr val="232C3A"/>
                 </a:solidFill>
                 <a:latin typeface="Calibri" pitchFamily="34" charset="0"/>
                 <a:ea typeface="Calibri" pitchFamily="34" charset="-122"/>
@@ -18697,7 +18697,7 @@
             <a:r>
               <a:rPr lang="en-US" sz="960" b="1" spc="110" kern="0" dirty="0">
                 <a:solidFill>
-                  <a:srgbClr val="6B7A90"/>
+                  <a:srgbClr val="232C3A"/>
                 </a:solidFill>
                 <a:latin typeface="Calibri" pitchFamily="34" charset="0"/>
                 <a:ea typeface="Calibri" pitchFamily="34" charset="-122"/>
@@ -18802,7 +18802,7 @@
             <a:r>
               <a:rPr lang="en-US" sz="940" dirty="0">
                 <a:solidFill>
-                  <a:srgbClr val="6B7A90"/>
+                  <a:srgbClr val="232C3A"/>
                 </a:solidFill>
                 <a:latin typeface="Calibri" pitchFamily="34" charset="0"/>
                 <a:ea typeface="Calibri" pitchFamily="34" charset="-122"/>
@@ -18831,11 +18831,11 @@
             </a:avLst>
           </a:prstGeom>
           <a:solidFill>
-            <a:srgbClr val="4FC3E8"/>
+            <a:srgbClr val="12235B"/>
           </a:solidFill>
           <a:ln w="13970">
             <a:solidFill>
-              <a:srgbClr val="4FC3E8"/>
+              <a:srgbClr val="12235B"/>
             </a:solidFill>
             <a:prstDash val="solid"/>
           </a:ln>
@@ -18907,7 +18907,7 @@
             <a:r>
               <a:rPr lang="en-US" sz="940" dirty="0">
                 <a:solidFill>
-                  <a:srgbClr val="6B7A90"/>
+                  <a:srgbClr val="9FD9F0"/>
                 </a:solidFill>
                 <a:latin typeface="Calibri" pitchFamily="34" charset="0"/>
                 <a:ea typeface="Calibri" pitchFamily="34" charset="-122"/>
@@ -19012,7 +19012,7 @@
             <a:r>
               <a:rPr lang="en-US" sz="940" dirty="0">
                 <a:solidFill>
-                  <a:srgbClr val="6B7A90"/>
+                  <a:srgbClr val="232C3A"/>
                 </a:solidFill>
                 <a:latin typeface="Calibri" pitchFamily="34" charset="0"/>
                 <a:ea typeface="Calibri" pitchFamily="34" charset="-122"/>
@@ -19117,7 +19117,7 @@
             <a:r>
               <a:rPr lang="en-US" sz="940" dirty="0">
                 <a:solidFill>
-                  <a:srgbClr val="6B7A90"/>
+                  <a:srgbClr val="232C3A"/>
                 </a:solidFill>
                 <a:latin typeface="Calibri" pitchFamily="34" charset="0"/>
                 <a:ea typeface="Calibri" pitchFamily="34" charset="-122"/>
@@ -19387,7 +19387,7 @@
             <a:r>
               <a:rPr lang="en-US" sz="960" b="1" spc="110" kern="0" dirty="0">
                 <a:solidFill>
-                  <a:srgbClr val="6B7A90"/>
+                  <a:srgbClr val="232C3A"/>
                 </a:solidFill>
                 <a:latin typeface="Calibri" pitchFamily="34" charset="0"/>
                 <a:ea typeface="Calibri" pitchFamily="34" charset="-122"/>
@@ -19492,7 +19492,7 @@
             <a:r>
               <a:rPr lang="en-US" sz="940" dirty="0">
                 <a:solidFill>
-                  <a:srgbClr val="6B7A90"/>
+                  <a:srgbClr val="232C3A"/>
                 </a:solidFill>
                 <a:latin typeface="Calibri" pitchFamily="34" charset="0"/>
                 <a:ea typeface="Calibri" pitchFamily="34" charset="-122"/>
@@ -19597,7 +19597,7 @@
             <a:r>
               <a:rPr lang="en-US" sz="940" dirty="0">
                 <a:solidFill>
-                  <a:srgbClr val="6B7A90"/>
+                  <a:srgbClr val="232C3A"/>
                 </a:solidFill>
                 <a:latin typeface="Calibri" pitchFamily="34" charset="0"/>
                 <a:ea typeface="Calibri" pitchFamily="34" charset="-122"/>
@@ -19702,7 +19702,7 @@
             <a:r>
               <a:rPr lang="en-US" sz="940" dirty="0">
                 <a:solidFill>
-                  <a:srgbClr val="6B7A90"/>
+                  <a:srgbClr val="232C3A"/>
                 </a:solidFill>
                 <a:latin typeface="Calibri" pitchFamily="34" charset="0"/>
                 <a:ea typeface="Calibri" pitchFamily="34" charset="-122"/>
@@ -19807,7 +19807,7 @@
             <a:r>
               <a:rPr lang="en-US" sz="940" dirty="0">
                 <a:solidFill>
-                  <a:srgbClr val="6B7A90"/>
+                  <a:srgbClr val="232C3A"/>
                 </a:solidFill>
                 <a:latin typeface="Calibri" pitchFamily="34" charset="0"/>
                 <a:ea typeface="Calibri" pitchFamily="34" charset="-122"/>
@@ -19870,7 +19870,7 @@
             <a:r>
               <a:rPr lang="en-US" sz="960" dirty="0">
                 <a:solidFill>
-                  <a:srgbClr val="6B7A90"/>
+                  <a:srgbClr val="232C3A"/>
                 </a:solidFill>
                 <a:latin typeface="Calibri" pitchFamily="34" charset="0"/>
                 <a:ea typeface="Calibri" pitchFamily="34" charset="-122"/>
@@ -19936,7 +19936,7 @@
             <a:r>
               <a:rPr lang="en-US" sz="960" b="1" spc="110" kern="0" dirty="0">
                 <a:solidFill>
-                  <a:srgbClr val="6B7A90"/>
+                  <a:srgbClr val="232C3A"/>
                 </a:solidFill>
                 <a:latin typeface="Calibri" pitchFamily="34" charset="0"/>
                 <a:ea typeface="Calibri" pitchFamily="34" charset="-122"/>
@@ -19969,7 +19969,7 @@
           </a:solidFill>
           <a:ln w="13970">
             <a:solidFill>
-              <a:srgbClr val="6B7A90"/>
+              <a:srgbClr val="232C3A"/>
             </a:solidFill>
             <a:prstDash val="solid"/>
           </a:ln>
@@ -20041,7 +20041,7 @@
             <a:r>
               <a:rPr lang="en-US" sz="940" dirty="0">
                 <a:solidFill>
-                  <a:srgbClr val="6B7A90"/>
+                  <a:srgbClr val="232C3A"/>
                 </a:solidFill>
                 <a:latin typeface="Calibri" pitchFamily="34" charset="0"/>
                 <a:ea typeface="Calibri" pitchFamily="34" charset="-122"/>
@@ -20146,7 +20146,7 @@
             <a:r>
               <a:rPr lang="en-US" sz="940" dirty="0">
                 <a:solidFill>
-                  <a:srgbClr val="6B7A90"/>
+                  <a:srgbClr val="232C3A"/>
                 </a:solidFill>
                 <a:latin typeface="Calibri" pitchFamily="34" charset="0"/>
                 <a:ea typeface="Calibri" pitchFamily="34" charset="-122"/>
@@ -20251,7 +20251,7 @@
             <a:r>
               <a:rPr lang="en-US" sz="940" dirty="0">
                 <a:solidFill>
-                  <a:srgbClr val="6B7A90"/>
+                  <a:srgbClr val="232C3A"/>
                 </a:solidFill>
                 <a:latin typeface="Calibri" pitchFamily="34" charset="0"/>
                 <a:ea typeface="Calibri" pitchFamily="34" charset="-122"/>
@@ -20280,7 +20280,7 @@
           <a:noFill/>
           <a:ln w="19050">
             <a:solidFill>
-              <a:srgbClr val="6B7A90"/>
+              <a:srgbClr val="232C3A"/>
             </a:solidFill>
             <a:prstDash val="dash"/>
             <a:tailEnd type="triangle"/>
@@ -20362,7 +20362,7 @@
             <a:r>
               <a:rPr lang="en-US" sz="960" i="1" dirty="0">
                 <a:solidFill>
-                  <a:srgbClr val="6B7A90"/>
+                  <a:srgbClr val="232C3A"/>
                 </a:solidFill>
                 <a:latin typeface="Calibri" pitchFamily="34" charset="0"/>
                 <a:ea typeface="Calibri" pitchFamily="34" charset="-122"/>
@@ -20401,7 +20401,7 @@
             <a:r>
               <a:rPr lang="en-US" sz="950" dirty="0">
                 <a:solidFill>
-                  <a:srgbClr val="6B7A90"/>
+                  <a:srgbClr val="232C3A"/>
                 </a:solidFill>
                 <a:latin typeface="Calibri" pitchFamily="34" charset="0"/>
                 <a:ea typeface="Calibri" pitchFamily="34" charset="-122"/>
@@ -21622,7 +21622,7 @@
             <a:r>
               <a:rPr lang="en-US" sz="1300" b="1" dirty="0">
                 <a:solidFill>
-                  <a:srgbClr val="FFFFFF"/>
+                  <a:srgbClr val="12235B"/>
                 </a:solidFill>
                 <a:latin typeface="Calibri" pitchFamily="34" charset="0"/>
                 <a:ea typeface="Calibri" pitchFamily="34" charset="-122"/>
@@ -21947,7 +21947,7 @@
             <a:r>
               <a:rPr lang="en-US" sz="950" dirty="0">
                 <a:solidFill>
-                  <a:srgbClr val="6B7A90"/>
+                  <a:srgbClr val="232C3A"/>
                 </a:solidFill>
                 <a:latin typeface="Calibri" pitchFamily="34" charset="0"/>
                 <a:ea typeface="Calibri" pitchFamily="34" charset="-122"/>
@@ -22185,7 +22185,7 @@
             <a:r>
               <a:rPr lang="en-US" sz="1020" i="1" dirty="0">
                 <a:solidFill>
-                  <a:srgbClr val="6B7A90"/>
+                  <a:srgbClr val="232C3A"/>
                 </a:solidFill>
                 <a:latin typeface="Calibri" pitchFamily="34" charset="0"/>
                 <a:ea typeface="Calibri" pitchFamily="34" charset="-122"/>
@@ -22293,7 +22293,7 @@
             <a:r>
               <a:rPr lang="en-US" sz="980" dirty="0">
                 <a:solidFill>
-                  <a:srgbClr val="6B7A90"/>
+                  <a:srgbClr val="232C3A"/>
                 </a:solidFill>
                 <a:latin typeface="Calibri" pitchFamily="34" charset="0"/>
                 <a:ea typeface="Calibri" pitchFamily="34" charset="-122"/>
@@ -22401,7 +22401,7 @@
             <a:r>
               <a:rPr lang="en-US" sz="980" dirty="0">
                 <a:solidFill>
-                  <a:srgbClr val="6B7A90"/>
+                  <a:srgbClr val="232C3A"/>
                 </a:solidFill>
                 <a:latin typeface="Calibri" pitchFamily="34" charset="0"/>
                 <a:ea typeface="Calibri" pitchFamily="34" charset="-122"/>
@@ -22509,7 +22509,7 @@
             <a:r>
               <a:rPr lang="en-US" sz="980" dirty="0">
                 <a:solidFill>
-                  <a:srgbClr val="6B7A90"/>
+                  <a:srgbClr val="232C3A"/>
                 </a:solidFill>
                 <a:latin typeface="Calibri" pitchFamily="34" charset="0"/>
                 <a:ea typeface="Calibri" pitchFamily="34" charset="-122"/>
@@ -22617,7 +22617,7 @@
             <a:r>
               <a:rPr lang="en-US" sz="980" dirty="0">
                 <a:solidFill>
-                  <a:srgbClr val="6B7A90"/>
+                  <a:srgbClr val="232C3A"/>
                 </a:solidFill>
                 <a:latin typeface="Calibri" pitchFamily="34" charset="0"/>
                 <a:ea typeface="Calibri" pitchFamily="34" charset="-122"/>
@@ -22857,7 +22857,7 @@
             <a:r>
               <a:rPr lang="en-US" sz="950" dirty="0">
                 <a:solidFill>
-                  <a:srgbClr val="6B7A90"/>
+                  <a:srgbClr val="232C3A"/>
                 </a:solidFill>
                 <a:latin typeface="Calibri" pitchFamily="34" charset="0"/>
                 <a:ea typeface="Calibri" pitchFamily="34" charset="-122"/>

</xml_diff>